<commit_message>
fix(portadas-presentacion): grupo 005, salon 7208, jueves M4-M6, eliminar brigada, layout vertical en diapositivas 02-04 y maquinas completas
</commit_message>
<xml_diff>
--- a/01_DOCUMENTOS_ACADEMICOS_FIME/Presentacion_ExpendeX_Contexto_Mercado_y_Negocio.pptx
+++ b/01_DOCUMENTOS_ACADEMICOS_FIME/Presentacion_ExpendeX_Contexto_Mercado_y_Negocio.pptx
@@ -3247,7 +3247,7 @@
                 </a:solidFill>
                 <a:latin typeface="Calibri"/>
               </a:rPr>
-              <a:t>MICRO-RESTAURANTE AUTOMATIZADO DESATENDIDO DE COMIDA CASERA Y BEBIDAS</a:t>
+              <a:t>MÁQUINA AUTOMATIZADA HÍBRIDA AUTOMATIZADO DESATENDIDO DE COMIDA CASERA Y BEBIDAS</a:t>
             </a:r>
           </a:p>
           <a:p>
@@ -3511,7 +3511,7 @@
                 </a:solidFill>
                 <a:latin typeface="Calibri"/>
               </a:rPr>
-              <a:t>Grupo: 001 | Brigada: 107 | Semestre: Agosto – Diciembre 2026</a:t>
+              <a:t>Grupo: 001 | Grupo: 005 | Salón: 7208 | Jueves M4 a M6 | Semestre: Agosto – Diciembre 2026</a:t>
             </a:r>
           </a:p>
         </p:txBody>
@@ -3867,7 +3867,7 @@
                 </a:solidFill>
                 <a:latin typeface="Calibri"/>
               </a:rPr>
-              <a:t>UANL - FIME | Proyecto Final: Micro-Restaurante ExpendeX (Contexto, Mercado, Competencia y Rendimiento) | Ing. Mario Alberto González Vázquez</a:t>
+              <a:t>UANL - FIME | Proyecto Final: Máquina Automatizada Híbrida ExpendeX (Contexto, Mercado, Competencia y Rendimiento) | Ing. Mario Alberto González Vázquez</a:t>
             </a:r>
           </a:p>
         </p:txBody>
@@ -4202,7 +4202,7 @@
                 </a:solidFill>
                 <a:latin typeface="Calibri"/>
               </a:rPr>
-              <a:t>UANL - FIME | Proyecto Final: Micro-Restaurante ExpendeX (Contexto, Mercado, Competencia y Rendimiento) | Ing. Mario Alberto González Vázquez</a:t>
+              <a:t>UANL - FIME | Proyecto Final: Máquina Automatizada Híbrida ExpendeX (Contexto, Mercado, Competencia y Rendimiento) | Ing. Mario Alberto González Vázquez</a:t>
             </a:r>
           </a:p>
         </p:txBody>
@@ -5353,7 +5353,7 @@
                 </a:solidFill>
                 <a:latin typeface="Calibri"/>
               </a:rPr>
-              <a:t>UANL - FIME | Proyecto Final: Micro-Restaurante ExpendeX (Contexto, Mercado, Competencia y Rendimiento) | Ing. Mario Alberto González Vázquez</a:t>
+              <a:t>UANL - FIME | Proyecto Final: Máquina Automatizada Híbrida ExpendeX (Contexto, Mercado, Competencia y Rendimiento) | Ing. Mario Alberto González Vázquez</a:t>
             </a:r>
           </a:p>
         </p:txBody>
@@ -5941,7 +5941,7 @@
                 </a:solidFill>
                 <a:latin typeface="Calibri"/>
               </a:rPr>
-              <a:t>UANL - FIME | Proyecto Final: Micro-Restaurante ExpendeX (Contexto, Mercado, Competencia y Rendimiento) | Ing. Mario Alberto González Vázquez</a:t>
+              <a:t>UANL - FIME | Proyecto Final: Máquina Automatizada Híbrida ExpendeX (Contexto, Mercado, Competencia y Rendimiento) | Ing. Mario Alberto González Vázquez</a:t>
             </a:r>
           </a:p>
         </p:txBody>
@@ -6963,7 +6963,7 @@
                 </a:solidFill>
                 <a:latin typeface="Calibri"/>
               </a:rPr>
-              <a:t>UANL - FIME | Proyecto Final: Micro-Restaurante ExpendeX (Contexto, Mercado, Competencia y Rendimiento) | Ing. Mario Alberto González Vázquez</a:t>
+              <a:t>UANL - FIME | Proyecto Final: Máquina Automatizada Híbrida ExpendeX (Contexto, Mercado, Competencia y Rendimiento) | Ing. Mario Alberto González Vázquez</a:t>
             </a:r>
           </a:p>
         </p:txBody>
@@ -8301,7 +8301,7 @@
                 </a:solidFill>
                 <a:latin typeface="Calibri"/>
               </a:rPr>
-              <a:t>UANL - FIME | Proyecto Final: Micro-Restaurante ExpendeX (Contexto, Mercado, Competencia y Rendimiento) | Ing. Mario Alberto González Vázquez</a:t>
+              <a:t>UANL - FIME | Proyecto Final: Máquina Automatizada Híbrida ExpendeX (Contexto, Mercado, Competencia y Rendimiento) | Ing. Mario Alberto González Vázquez</a:t>
             </a:r>
           </a:p>
         </p:txBody>
@@ -8989,7 +8989,7 @@
                 </a:solidFill>
                 <a:latin typeface="Calibri"/>
               </a:rPr>
-              <a:t>UANL - FIME | Proyecto Final: Micro-Restaurante ExpendeX (Contexto, Mercado, Competencia y Rendimiento) | Ing. Mario Alberto González Vázquez</a:t>
+              <a:t>UANL - FIME | Proyecto Final: Máquina Automatizada Híbrida ExpendeX (Contexto, Mercado, Competencia y Rendimiento) | Ing. Mario Alberto González Vázquez</a:t>
             </a:r>
           </a:p>
         </p:txBody>
@@ -10104,7 +10104,7 @@
                 </a:solidFill>
                 <a:latin typeface="Calibri"/>
               </a:rPr>
-              <a:t>UANL - FIME | Proyecto Final: Micro-Restaurante ExpendeX (Contexto, Mercado, Competencia y Rendimiento) | Ing. Mario Alberto González Vázquez</a:t>
+              <a:t>UANL - FIME | Proyecto Final: Máquina Automatizada Híbrida ExpendeX (Contexto, Mercado, Competencia y Rendimiento) | Ing. Mario Alberto González Vázquez</a:t>
             </a:r>
           </a:p>
         </p:txBody>
@@ -10717,7 +10717,7 @@
                 </a:solidFill>
                 <a:latin typeface="Calibri"/>
               </a:rPr>
-              <a:t>UANL - FIME | Proyecto Final: Micro-Restaurante ExpendeX (Contexto, Mercado, Competencia y Rendimiento) | Ing. Mario Alberto González Vázquez</a:t>
+              <a:t>UANL - FIME | Proyecto Final: Máquina Automatizada Híbrida ExpendeX (Contexto, Mercado, Competencia y Rendimiento) | Ing. Mario Alberto González Vázquez</a:t>
             </a:r>
           </a:p>
         </p:txBody>
@@ -11739,7 +11739,7 @@
                 </a:solidFill>
                 <a:latin typeface="Calibri"/>
               </a:rPr>
-              <a:t>UANL - FIME | Proyecto Final: Micro-Restaurante ExpendeX (Contexto, Mercado, Competencia y Rendimiento) | Ing. Mario Alberto González Vázquez</a:t>
+              <a:t>UANL - FIME | Proyecto Final: Máquina Automatizada Híbrida ExpendeX (Contexto, Mercado, Competencia y Rendimiento) | Ing. Mario Alberto González Vázquez</a:t>
             </a:r>
           </a:p>
         </p:txBody>
@@ -12840,7 +12840,7 @@
                 </a:solidFill>
                 <a:latin typeface="Calibri"/>
               </a:rPr>
-              <a:t>UANL - FIME | Proyecto Final: Micro-Restaurante ExpendeX (Contexto, Mercado, Competencia y Rendimiento) | Ing. Mario Alberto González Vázquez</a:t>
+              <a:t>UANL - FIME | Proyecto Final: Máquina Automatizada Híbrida ExpendeX (Contexto, Mercado, Competencia y Rendimiento) | Ing. Mario Alberto González Vázquez</a:t>
             </a:r>
           </a:p>
         </p:txBody>
@@ -13787,7 +13787,7 @@
                 </a:solidFill>
                 <a:latin typeface="Calibri"/>
               </a:rPr>
-              <a:t>UANL - FIME | Proyecto Final: Micro-Restaurante ExpendeX (Contexto, Mercado, Competencia y Rendimiento) | Ing. Mario Alberto González Vázquez</a:t>
+              <a:t>UANL - FIME | Proyecto Final: Máquina Automatizada Híbrida ExpendeX (Contexto, Mercado, Competencia y Rendimiento) | Ing. Mario Alberto González Vázquez</a:t>
             </a:r>
           </a:p>
         </p:txBody>
@@ -14630,7 +14630,7 @@
                 </a:solidFill>
                 <a:latin typeface="Calibri"/>
               </a:rPr>
-              <a:t>UANL - FIME | Proyecto Final: Micro-Restaurante ExpendeX (Contexto, Mercado, Competencia y Rendimiento) | Ing. Mario Alberto González Vázquez</a:t>
+              <a:t>UANL - FIME | Proyecto Final: Máquina Automatizada Híbrida ExpendeX (Contexto, Mercado, Competencia y Rendimiento) | Ing. Mario Alberto González Vázquez</a:t>
             </a:r>
           </a:p>
         </p:txBody>
@@ -15393,7 +15393,7 @@
                 </a:solidFill>
                 <a:latin typeface="Calibri"/>
               </a:rPr>
-              <a:t>UANL - FIME | Proyecto Final: Micro-Restaurante ExpendeX (Contexto, Mercado, Competencia y Rendimiento) | Ing. Mario Alberto González Vázquez</a:t>
+              <a:t>UANL - FIME | Proyecto Final: Máquina Automatizada Híbrida ExpendeX (Contexto, Mercado, Competencia y Rendimiento) | Ing. Mario Alberto González Vázquez</a:t>
             </a:r>
           </a:p>
         </p:txBody>
@@ -16597,7 +16597,7 @@
                 </a:solidFill>
                 <a:latin typeface="Calibri"/>
               </a:rPr>
-              <a:t>UANL - FIME | Proyecto Final: Micro-Restaurante ExpendeX (Contexto, Mercado, Competencia y Rendimiento) | Ing. Mario Alberto González Vázquez</a:t>
+              <a:t>UANL - FIME | Proyecto Final: Máquina Automatizada Híbrida ExpendeX (Contexto, Mercado, Competencia y Rendimiento) | Ing. Mario Alberto González Vázquez</a:t>
             </a:r>
           </a:p>
         </p:txBody>
@@ -17619,7 +17619,7 @@
                 </a:solidFill>
                 <a:latin typeface="Calibri"/>
               </a:rPr>
-              <a:t>UANL - FIME | Proyecto Final: Micro-Restaurante ExpendeX (Contexto, Mercado, Competencia y Rendimiento) | Ing. Mario Alberto González Vázquez</a:t>
+              <a:t>UANL - FIME | Proyecto Final: Máquina Automatizada Híbrida ExpendeX (Contexto, Mercado, Competencia y Rendimiento) | Ing. Mario Alberto González Vázquez</a:t>
             </a:r>
           </a:p>
         </p:txBody>
@@ -18988,7 +18988,7 @@
                 </a:solidFill>
                 <a:latin typeface="Calibri"/>
               </a:rPr>
-              <a:t>UANL - FIME | Proyecto Final: Micro-Restaurante ExpendeX (Contexto, Mercado, Competencia y Rendimiento) | Ing. Mario Alberto González Vázquez</a:t>
+              <a:t>UANL - FIME | Proyecto Final: Máquina Automatizada Híbrida ExpendeX (Contexto, Mercado, Competencia y Rendimiento) | Ing. Mario Alberto González Vázquez</a:t>
             </a:r>
           </a:p>
         </p:txBody>
@@ -19831,7 +19831,7 @@
                 </a:solidFill>
                 <a:latin typeface="Calibri"/>
               </a:rPr>
-              <a:t>UANL - FIME | Proyecto Final: Micro-Restaurante ExpendeX (Contexto, Mercado, Competencia y Rendimiento) | Ing. Mario Alberto González Vázquez</a:t>
+              <a:t>UANL - FIME | Proyecto Final: Máquina Automatizada Híbrida ExpendeX (Contexto, Mercado, Competencia y Rendimiento) | Ing. Mario Alberto González Vázquez</a:t>
             </a:r>
           </a:p>
         </p:txBody>
@@ -20045,7 +20045,7 @@
                 </a:solidFill>
                 <a:latin typeface="Calibri"/>
               </a:rPr>
-              <a:t>Hambre voraz entre clases, filas de 35 minutos en cafeterías, comer botanas chatarras y gastar hasta $200 MXN en delivery.</a:t>
+              <a:t>Hambre voraz entre clases, filas de 20 minutos en cafeterías, comer botanas chatarras y gastar hasta $200 MXN en delivery.</a:t>
             </a:r>
           </a:p>
           <a:p>
@@ -20710,7 +20710,7 @@
                 </a:solidFill>
                 <a:latin typeface="Calibri"/>
               </a:rPr>
-              <a:t>LA SOLUCIÓN: EXPENDEX — EL MICRO-RESTAURANTE AUTOMATIZADO</a:t>
+              <a:t>LA SOLUCIÓN: EXPENDEX — EL MÁQUINA AUTOMATIZADA HÍBRIDA AUTOMATIZADO</a:t>
             </a:r>
           </a:p>
           <a:p>
@@ -20853,7 +20853,7 @@
                 </a:solidFill>
                 <a:latin typeface="Calibri"/>
               </a:rPr>
-              <a:t>UANL - FIME | Proyecto Final: Micro-Restaurante ExpendeX (Contexto, Mercado, Competencia y Rendimiento) | Ing. Mario Alberto González Vázquez</a:t>
+              <a:t>UANL - FIME | Proyecto Final: Máquina Automatizada Híbrida ExpendeX (Contexto, Mercado, Competencia y Rendimiento) | Ing. Mario Alberto González Vázquez</a:t>
             </a:r>
           </a:p>
         </p:txBody>
@@ -21441,7 +21441,7 @@
                 </a:solidFill>
                 <a:latin typeface="Calibri"/>
               </a:rPr>
-              <a:t>UANL - FIME | Proyecto Final: Micro-Restaurante ExpendeX (Contexto, Mercado, Competencia y Rendimiento) | Ing. Mario Alberto González Vázquez</a:t>
+              <a:t>UANL - FIME | Proyecto Final: Máquina Automatizada Híbrida ExpendeX (Contexto, Mercado, Competencia y Rendimiento) | Ing. Mario Alberto González Vázquez</a:t>
             </a:r>
           </a:p>
         </p:txBody>

</xml_diff>